<commit_message>
Make the two-beat purpose explicit on the opening slides
State the claim itself as slide 2's title (no analysis expertise needed
to read trends out of operational data) and demote the two-barriers
device to supporting body copy. Close slide 2 with an explicit "here is
one example of that" declaration so the analysis that follows is heard
as a demonstration of the claim rather than as the deliverable.

Co-Authored-By: Claude Opus 5 <noreply@anthropic.com>
Claude-Session: https://claude.ai/code/session_01P8UinydFAyS1XyaeDLsy7k
</commit_message>
<xml_diff>
--- a/internship-presentation/DYNATREK_IB普及分析_成果発表.pptx
+++ b/internship-presentation/DYNATREK_IB普及分析_成果発表.pptx
@@ -510,7 +510,7 @@
               <a:t>本日は、2週間のインターンシップで取り組んだ内容についてご報告します。
 タイトルにあるとおり、今回私が扱ったのは「愛知銀行のインターネットバンキング、IBがどれくらい広がっているのか」という疑問です。
 ただ、本日一番お伝えしたいのは分析結果そのものではありません。
-専門的なデータ分析の知識がなくても、DYNATREKを使えば業務上の疑問をデータで確かめていける、ということを、実際に自分がやってみた分析を例にお話しします。</a:t>
+今日お伝えしたいのは、DYNATREKを使えば、データ分析の専門知識や経験がない人でも、業務データを集計して傾向をつかめる、ということです。そして今回は、その一例として、私が実際にやってみた分析をご紹介します。</a:t>
             </a:r>
             <a:endParaRPr lang="en-US" dirty="0"/>
           </a:p>
@@ -599,12 +599,12 @@
             <a:r>
               <a:rPr lang="en-US" dirty="0"/>
               <a:t>まず、今回のテーマと背景です。愛知銀行ではIBの普及に向けた施策やキャンペーンが行われていて、では実際にどれくらい使われるようになったのか、を確かめたい、というのが出発点でした。
-実際に取り組んでみて感じたのは、業務上の疑問をデータで確かめようとすると、壁が2つあるということです。
+ここで、今日の主張をはっきりさせておきます。分析の専門知識や経験がなくても、業務データから傾向はつかめる、ということです。
+というのも、業務上の疑問をデータで確かめようとすると、壁が2つあるからです。
 壁①は「そもそも何を見れば答えになるのか」を決めること。これは人が考えるしかありません。
-壁②は「そのデータを業務DBから取り出す」こと。業務DBには分析に使わない項目も大量にあるので、ここでつまずくことが多いと思います。
-DYNATREKは、条件を指定して必要なデータだけを表示・集計できるツールで、この壁②を下げてくれます。
-つまり、専門的な分析の知識がなくても、壁①を考えることに時間を使える。ここが今日お伝えしたい一番のポイントです。
-では実際にどう考えたのか、次のスライドでご説明します。</a:t>
+壁②は「そのデータを業務DBから取り出す」こと。業務DBには分析に使わない項目も大量にあるので、専門知識がないとここでつまずきます。
+DYNATREKは条件を指定して必要なデータだけを表示・集計できるので、この壁②を引き受けてくれます。だから壁①を考えることに時間を使える。ここが一番のポイントです。
+そして今回は、その一例として、私が実際に行った分析をご紹介します。どう考えて、どう集計したのかを見ていただければと思います。</a:t>
             </a:r>
             <a:endParaRPr lang="en-US" dirty="0"/>
           </a:p>
@@ -1533,7 +1533,7 @@
                 <a:ea typeface="Meiryo" pitchFamily="34" charset="-122"/>
                 <a:cs typeface="Meiryo" pitchFamily="34" charset="-120"/>
               </a:rPr>
-              <a:t>専門的なデータ分析の知識がなくても、DYNATREKなら業務の疑問を確かめられる</a:t>
+              <a:t>分析の専門知識や経験がなくても、DYNATREKなら業務データから傾向をつかめる</a:t>
             </a:r>
             <a:endParaRPr lang="en-US" sz="1550" dirty="0"/>
           </a:p>
@@ -1748,7 +1748,7 @@
                 <a:ea typeface="Meiryo" pitchFamily="34" charset="-122"/>
                 <a:cs typeface="Meiryo" pitchFamily="34" charset="-120"/>
               </a:rPr>
-              <a:t>業務の疑問をデータで確かめるには、2つの壁がある</a:t>
+              <a:t>分析の専門知識や経験がなくても、データから傾向はつかめる</a:t>
             </a:r>
             <a:endParaRPr lang="en-US" sz="2600" dirty="0"/>
           </a:p>
@@ -1787,7 +1787,7 @@
                 <a:ea typeface="Meiryo" pitchFamily="34" charset="-122"/>
                 <a:cs typeface="Meiryo" pitchFamily="34" charset="-120"/>
               </a:rPr>
-              <a:t>専門知識がないと越えにくいのは「データを取り出す」壁。DYNATREKはそこを下げてくれる。</a:t>
+              <a:t>ネックになるのは「必要なデータを取り出す」ところ。DYNATREKがそこを引き受けるので、「何を見るか」に時間を使える。</a:t>
             </a:r>
             <a:endParaRPr lang="en-US" sz="1350" dirty="0"/>
           </a:p>
@@ -2465,7 +2465,7 @@
                 <a:ea typeface="Meiryo" pitchFamily="34" charset="-122"/>
                 <a:cs typeface="Meiryo" pitchFamily="34" charset="-120"/>
               </a:rPr>
-              <a:t>壁②が下がるからこそ、壁①を考えることに時間を使える。</a:t>
+              <a:t>今回は、その一例として行った分析を紹介します。</a:t>
             </a:r>
             <a:endParaRPr lang="en-US" sz="1350" dirty="0"/>
           </a:p>

</xml_diff>